<commit_message>
relatório Java POO ... 08Jun2024
</commit_message>
<xml_diff>
--- a/03 Assessments/PPT Projeto Multidisciplinar Yduqs Wyden UniRuy 2024.pptx
+++ b/03 Assessments/PPT Projeto Multidisciplinar Yduqs Wyden UniRuy 2024.pptx
@@ -5,7 +5,7 @@
     <p:sldMasterId id="2147483648" r:id="rId4"/>
   </p:sldMasterIdLst>
   <p:notesMasterIdLst>
-    <p:notesMasterId r:id="rId30"/>
+    <p:notesMasterId r:id="rId29"/>
   </p:notesMasterIdLst>
   <p:sldIdLst>
     <p:sldId id="256" r:id="rId5"/>
@@ -30,9 +30,8 @@
     <p:sldId id="1448944870" r:id="rId24"/>
     <p:sldId id="1448944872" r:id="rId25"/>
     <p:sldId id="1448944871" r:id="rId26"/>
-    <p:sldId id="1448944873" r:id="rId27"/>
-    <p:sldId id="1448944851" r:id="rId28"/>
-    <p:sldId id="259" r:id="rId29"/>
+    <p:sldId id="1448944851" r:id="rId27"/>
+    <p:sldId id="259" r:id="rId28"/>
   </p:sldIdLst>
   <p:sldSz cx="9144000" cy="5143500" type="screen16x9"/>
   <p:notesSz cx="6858000" cy="9144000"/>
@@ -3974,7 +3973,7 @@
           </a:ln>
           <a:extLst>
             <a:ext uri="{C572A759-6A51-4108-AA02-DFA0A04FC94B}">
-              <ma14:wrappingTextBoxFlag xmlns:ma14="http://schemas.microsoft.com/office/mac/drawingml/2011/main" xmlns="" val="1"/>
+              <ma14:wrappingTextBoxFlag xmlns="" xmlns:ma14="http://schemas.microsoft.com/office/mac/drawingml/2011/main" val="1"/>
             </a:ext>
           </a:extLst>
         </p:spPr>
@@ -4023,7 +4022,7 @@
           </a:ln>
           <a:extLst>
             <a:ext uri="{C572A759-6A51-4108-AA02-DFA0A04FC94B}">
-              <ma14:wrappingTextBoxFlag xmlns:ma14="http://schemas.microsoft.com/office/mac/drawingml/2011/main" xmlns="" val="1"/>
+              <ma14:wrappingTextBoxFlag xmlns="" xmlns:ma14="http://schemas.microsoft.com/office/mac/drawingml/2011/main" val="1"/>
             </a:ext>
           </a:extLst>
         </p:spPr>
@@ -4994,7 +4993,7 @@
           </a:ln>
           <a:extLst>
             <a:ext uri="{C572A759-6A51-4108-AA02-DFA0A04FC94B}">
-              <ma14:wrappingTextBoxFlag xmlns:ma14="http://schemas.microsoft.com/office/mac/drawingml/2011/main" xmlns="" val="1"/>
+              <ma14:wrappingTextBoxFlag xmlns="" xmlns:ma14="http://schemas.microsoft.com/office/mac/drawingml/2011/main" val="1"/>
             </a:ext>
           </a:extLst>
         </p:spPr>
@@ -5373,7 +5372,7 @@
           </a:ln>
           <a:extLst>
             <a:ext uri="{C572A759-6A51-4108-AA02-DFA0A04FC94B}">
-              <ma14:wrappingTextBoxFlag xmlns:ma14="http://schemas.microsoft.com/office/mac/drawingml/2011/main" xmlns="" val="1"/>
+              <ma14:wrappingTextBoxFlag xmlns="" xmlns:ma14="http://schemas.microsoft.com/office/mac/drawingml/2011/main" val="1"/>
             </a:ext>
           </a:extLst>
         </p:spPr>
@@ -5690,7 +5689,7 @@
           </a:ln>
           <a:extLst>
             <a:ext uri="{C572A759-6A51-4108-AA02-DFA0A04FC94B}">
-              <ma14:wrappingTextBoxFlag xmlns:ma14="http://schemas.microsoft.com/office/mac/drawingml/2011/main" xmlns="" val="1"/>
+              <ma14:wrappingTextBoxFlag xmlns="" xmlns:ma14="http://schemas.microsoft.com/office/mac/drawingml/2011/main" val="1"/>
             </a:ext>
           </a:extLst>
         </p:spPr>
@@ -8047,7 +8046,7 @@
                 <a:ea typeface="+mn-ea"/>
                 <a:cs typeface="+mn-cs"/>
               </a:rPr>
-              <a:t>PBL – Tópicos com Python Big Data</a:t>
+              <a:t>PBL – Tópicos Python Big Data</a:t>
             </a:r>
           </a:p>
           <a:p>
@@ -8118,10 +8117,10 @@
       </p:sp>
       <p:pic>
         <p:nvPicPr>
-          <p:cNvPr id="11" name="Imagem 10" descr="Grupo de pessoas posando para foto em frente a tela de projeção&#10;&#10;Descrição gerada automaticamente com confiança média">
+          <p:cNvPr id="2" name="Imagem 1" descr="Uma imagem contendo teto, no interior, pessoa, em pé&#10;&#10;Descrição gerada automaticamente">
             <a:extLst>
               <a:ext uri="{FF2B5EF4-FFF2-40B4-BE49-F238E27FC236}">
-                <a16:creationId xmlns:a16="http://schemas.microsoft.com/office/drawing/2014/main" id="{35DA1AF6-FF40-9773-BB40-CF9526305E58}"/>
+                <a16:creationId xmlns:a16="http://schemas.microsoft.com/office/drawing/2014/main" id="{498C54B0-A8B6-5431-9AC0-0121DC28B2DF}"/>
               </a:ext>
             </a:extLst>
           </p:cNvPr>
@@ -8144,80 +8143,8 @@
         </p:blipFill>
         <p:spPr>
           <a:xfrm>
-            <a:off x="119849" y="3419411"/>
-            <a:ext cx="2276785" cy="1701897"/>
-          </a:xfrm>
-          <a:prstGeom prst="rect">
-            <a:avLst/>
-          </a:prstGeom>
-        </p:spPr>
-      </p:pic>
-      <p:pic>
-        <p:nvPicPr>
-          <p:cNvPr id="19" name="Imagem 18" descr="Grupo de pessoas posando para foto em frente a parede azul&#10;&#10;Descrição gerada automaticamente com confiança média">
-            <a:extLst>
-              <a:ext uri="{FF2B5EF4-FFF2-40B4-BE49-F238E27FC236}">
-                <a16:creationId xmlns:a16="http://schemas.microsoft.com/office/drawing/2014/main" id="{44073BD4-FAE5-7379-06EC-CF82A55C3743}"/>
-              </a:ext>
-            </a:extLst>
-          </p:cNvPr>
-          <p:cNvPicPr>
-            <a:picLocks noChangeAspect="1"/>
-          </p:cNvPicPr>
-          <p:nvPr/>
-        </p:nvPicPr>
-        <p:blipFill>
-          <a:blip r:embed="rId7" cstate="print">
-            <a:extLst>
-              <a:ext uri="{28A0092B-C50C-407E-A947-70E740481C1C}">
-                <a14:useLocalDpi xmlns:a14="http://schemas.microsoft.com/office/drawing/2010/main" val="0"/>
-              </a:ext>
-            </a:extLst>
-          </a:blip>
-          <a:stretch>
-            <a:fillRect/>
-          </a:stretch>
-        </p:blipFill>
-        <p:spPr>
-          <a:xfrm>
-            <a:off x="2396635" y="3419410"/>
-            <a:ext cx="2276786" cy="1701898"/>
-          </a:xfrm>
-          <a:prstGeom prst="rect">
-            <a:avLst/>
-          </a:prstGeom>
-        </p:spPr>
-      </p:pic>
-      <p:pic>
-        <p:nvPicPr>
-          <p:cNvPr id="21" name="Imagem 20" descr="Uma imagem contendo pessoa, no interior, criança, jovem&#10;&#10;Descrição gerada automaticamente">
-            <a:extLst>
-              <a:ext uri="{FF2B5EF4-FFF2-40B4-BE49-F238E27FC236}">
-                <a16:creationId xmlns:a16="http://schemas.microsoft.com/office/drawing/2014/main" id="{AB9F4A50-B42C-5E45-84C3-D90D87C5CDE1}"/>
-              </a:ext>
-            </a:extLst>
-          </p:cNvPr>
-          <p:cNvPicPr>
-            <a:picLocks noChangeAspect="1"/>
-          </p:cNvPicPr>
-          <p:nvPr/>
-        </p:nvPicPr>
-        <p:blipFill>
-          <a:blip r:embed="rId8" cstate="print">
-            <a:extLst>
-              <a:ext uri="{28A0092B-C50C-407E-A947-70E740481C1C}">
-                <a14:useLocalDpi xmlns:a14="http://schemas.microsoft.com/office/drawing/2010/main" val="0"/>
-              </a:ext>
-            </a:extLst>
-          </a:blip>
-          <a:stretch>
-            <a:fillRect/>
-          </a:stretch>
-        </p:blipFill>
-        <p:spPr>
-          <a:xfrm>
-            <a:off x="4670258" y="1767135"/>
-            <a:ext cx="2520882" cy="3361176"/>
+            <a:off x="2705938" y="890122"/>
+            <a:ext cx="4489196" cy="3366897"/>
           </a:xfrm>
           <a:prstGeom prst="rect">
             <a:avLst/>
@@ -8627,124 +8554,6 @@
         </p:nvSpPr>
         <p:spPr>
           <a:xfrm>
-            <a:off x="934607" y="46468"/>
-            <a:ext cx="6087774" cy="942000"/>
-          </a:xfrm>
-          <a:prstGeom prst="flowChartDocument">
-            <a:avLst/>
-          </a:prstGeom>
-          <a:solidFill>
-            <a:srgbClr val="F00E3E"/>
-          </a:solidFill>
-        </p:spPr>
-        <p:txBody>
-          <a:bodyPr>
-            <a:normAutofit fontScale="90000"/>
-          </a:bodyPr>
-          <a:lstStyle/>
-          <a:p>
-            <a:pPr algn="ctr"/>
-            <a:r>
-              <a:rPr lang="pt-BR" dirty="0">
-                <a:solidFill>
-                  <a:schemeClr val="bg1"/>
-                </a:solidFill>
-              </a:rPr>
-              <a:t>Fotos Eventos Java POO</a:t>
-            </a:r>
-            <a:endParaRPr lang="en-US" dirty="0">
-              <a:solidFill>
-                <a:schemeClr val="bg1"/>
-              </a:solidFill>
-            </a:endParaRPr>
-          </a:p>
-        </p:txBody>
-      </p:sp>
-      <p:pic>
-        <p:nvPicPr>
-          <p:cNvPr id="18" name="Imagem 17" descr="Uma imagem contendo teto, no interior, pessoa, em pé&#10;&#10;Descrição gerada automaticamente">
-            <a:extLst>
-              <a:ext uri="{FF2B5EF4-FFF2-40B4-BE49-F238E27FC236}">
-                <a16:creationId xmlns:a16="http://schemas.microsoft.com/office/drawing/2014/main" id="{EAE420B2-B1EB-EECE-8116-31ABE6ADB8FD}"/>
-              </a:ext>
-            </a:extLst>
-          </p:cNvPr>
-          <p:cNvPicPr>
-            <a:picLocks noChangeAspect="1"/>
-          </p:cNvPicPr>
-          <p:nvPr/>
-        </p:nvPicPr>
-        <p:blipFill>
-          <a:blip r:embed="rId2" cstate="print">
-            <a:extLst>
-              <a:ext uri="{28A0092B-C50C-407E-A947-70E740481C1C}">
-                <a14:useLocalDpi xmlns:a14="http://schemas.microsoft.com/office/drawing/2010/main" val="0"/>
-              </a:ext>
-            </a:extLst>
-          </a:blip>
-          <a:stretch>
-            <a:fillRect/>
-          </a:stretch>
-        </p:blipFill>
-        <p:spPr>
-          <a:xfrm>
-            <a:off x="1309200" y="1033624"/>
-            <a:ext cx="5338587" cy="4003940"/>
-          </a:xfrm>
-          <a:prstGeom prst="rect">
-            <a:avLst/>
-          </a:prstGeom>
-        </p:spPr>
-      </p:pic>
-    </p:spTree>
-    <p:extLst>
-      <p:ext uri="{BB962C8B-B14F-4D97-AF65-F5344CB8AC3E}">
-        <p14:creationId xmlns:p14="http://schemas.microsoft.com/office/powerpoint/2010/main" val="3384232840"/>
-      </p:ext>
-    </p:extLst>
-  </p:cSld>
-  <p:clrMapOvr>
-    <a:masterClrMapping/>
-  </p:clrMapOvr>
-  <p:transition spd="med"/>
-</p:sld>
-</file>
-
-<file path=ppt/slides/slide24.xml><?xml version="1.0" encoding="utf-8"?>
-<p:sld xmlns:a="http://schemas.openxmlformats.org/drawingml/2006/main" xmlns:r="http://schemas.openxmlformats.org/officeDocument/2006/relationships" xmlns:p="http://schemas.openxmlformats.org/presentationml/2006/main">
-  <p:cSld>
-    <p:spTree>
-      <p:nvGrpSpPr>
-        <p:cNvPr id="1" name=""/>
-        <p:cNvGrpSpPr/>
-        <p:nvPr/>
-      </p:nvGrpSpPr>
-      <p:grpSpPr>
-        <a:xfrm>
-          <a:off x="0" y="0"/>
-          <a:ext cx="0" cy="0"/>
-          <a:chOff x="0" y="0"/>
-          <a:chExt cx="0" cy="0"/>
-        </a:xfrm>
-      </p:grpSpPr>
-      <p:sp>
-        <p:nvSpPr>
-          <p:cNvPr id="6" name="Título 1">
-            <a:extLst>
-              <a:ext uri="{FF2B5EF4-FFF2-40B4-BE49-F238E27FC236}">
-                <a16:creationId xmlns:a16="http://schemas.microsoft.com/office/drawing/2014/main" id="{3DF4DE9F-E280-4DD5-A63B-3C136B01E07D}"/>
-              </a:ext>
-            </a:extLst>
-          </p:cNvPr>
-          <p:cNvSpPr>
-            <a:spLocks noGrp="1"/>
-          </p:cNvSpPr>
-          <p:nvPr>
-            <p:ph type="title"/>
-          </p:nvPr>
-        </p:nvSpPr>
-        <p:spPr>
-          <a:xfrm>
             <a:off x="1640239" y="306113"/>
             <a:ext cx="4866887" cy="942000"/>
           </a:xfrm>
@@ -8828,7 +8637,7 @@
 </p:sld>
 </file>
 
-<file path=ppt/slides/slide25.xml><?xml version="1.0" encoding="utf-8"?>
+<file path=ppt/slides/slide24.xml><?xml version="1.0" encoding="utf-8"?>
 <p:sld xmlns:a="http://schemas.openxmlformats.org/drawingml/2006/main" xmlns:r="http://schemas.openxmlformats.org/officeDocument/2006/relationships" xmlns:p="http://schemas.openxmlformats.org/presentationml/2006/main">
   <p:cSld>
     <p:spTree>
@@ -8872,7 +8681,7 @@
           </a:ln>
           <a:extLst>
             <a:ext uri="{C572A759-6A51-4108-AA02-DFA0A04FC94B}">
-              <ma14:wrappingTextBoxFlag xmlns:ma14="http://schemas.microsoft.com/office/mac/drawingml/2011/main" xmlns="" val="1"/>
+              <ma14:wrappingTextBoxFlag xmlns="" xmlns:ma14="http://schemas.microsoft.com/office/mac/drawingml/2011/main" val="1"/>
             </a:ext>
           </a:extLst>
         </p:spPr>
@@ -12877,6 +12686,12 @@
 </file>
 
 <file path=customXml/item2.xml><?xml version="1.0" encoding="utf-8"?>
+<p:properties xmlns:p="http://schemas.microsoft.com/office/2006/metadata/properties" xmlns:xsi="http://www.w3.org/2001/XMLSchema-instance" xmlns:pc="http://schemas.microsoft.com/office/infopath/2007/PartnerControls">
+  <documentManagement/>
+</p:properties>
+</file>
+
+<file path=customXml/item3.xml><?xml version="1.0" encoding="utf-8"?>
 <ct:contentTypeSchema xmlns:ct="http://schemas.microsoft.com/office/2006/metadata/contentType" xmlns:ma="http://schemas.microsoft.com/office/2006/metadata/properties/metaAttributes" ct:_="" ma:_="" ma:contentTypeName="Documento" ma:contentTypeID="0x010100E7E326A6FBD7C948AAF887265A2DB080" ma:contentTypeVersion="13" ma:contentTypeDescription="Crie um novo documento." ma:contentTypeScope="" ma:versionID="5629727caf6964b78819cfb788ada473">
   <xsd:schema xmlns:xsd="http://www.w3.org/2001/XMLSchema" xmlns:xs="http://www.w3.org/2001/XMLSchema" xmlns:p="http://schemas.microsoft.com/office/2006/metadata/properties" xmlns:ns2="bab2302b-9cf7-40b9-b316-803bc24ea342" xmlns:ns3="c298cbf6-df3b-44f4-88ee-2b3d9158f680" targetNamespace="http://schemas.microsoft.com/office/2006/metadata/properties" ma:root="true" ma:fieldsID="929990cc5bdd3bebd2af3f9d94cdeeec" ns2:_="" ns3:_="">
     <xsd:import namespace="bab2302b-9cf7-40b9-b316-803bc24ea342"/>
@@ -13099,12 +12914,6 @@
 </ct:contentTypeSchema>
 </file>
 
-<file path=customXml/item3.xml><?xml version="1.0" encoding="utf-8"?>
-<p:properties xmlns:p="http://schemas.microsoft.com/office/2006/metadata/properties" xmlns:xsi="http://www.w3.org/2001/XMLSchema-instance" xmlns:pc="http://schemas.microsoft.com/office/infopath/2007/PartnerControls">
-  <documentManagement/>
-</p:properties>
-</file>
-
 <file path=customXml/itemProps1.xml><?xml version="1.0" encoding="utf-8"?>
 <ds:datastoreItem xmlns:ds="http://schemas.openxmlformats.org/officeDocument/2006/customXml" ds:itemID="{AED456AD-07D2-43E3-AD57-2C9049066662}">
   <ds:schemaRefs>
@@ -13114,6 +12923,15 @@
 </file>
 
 <file path=customXml/itemProps2.xml><?xml version="1.0" encoding="utf-8"?>
+<ds:datastoreItem xmlns:ds="http://schemas.openxmlformats.org/officeDocument/2006/customXml" ds:itemID="{961A30F4-F1EA-4F98-A164-76D337EE5565}">
+  <ds:schemaRefs>
+    <ds:schemaRef ds:uri="http://schemas.microsoft.com/office/2006/metadata/properties"/>
+    <ds:schemaRef ds:uri="http://schemas.microsoft.com/office/infopath/2007/PartnerControls"/>
+  </ds:schemaRefs>
+</ds:datastoreItem>
+</file>
+
+<file path=customXml/itemProps3.xml><?xml version="1.0" encoding="utf-8"?>
 <ds:datastoreItem xmlns:ds="http://schemas.openxmlformats.org/officeDocument/2006/customXml" ds:itemID="{6A7BB859-CC6B-497C-9B96-0A0D80ADCD36}">
   <ds:schemaRefs>
     <ds:schemaRef ds:uri="http://schemas.microsoft.com/office/2006/metadata/contentType"/>
@@ -13130,13 +12948,4 @@
     <ds:schemaRef ds:uri="http://schemas.microsoft.com/internal/obd"/>
   </ds:schemaRefs>
 </ds:datastoreItem>
-</file>
-
-<file path=customXml/itemProps3.xml><?xml version="1.0" encoding="utf-8"?>
-<ds:datastoreItem xmlns:ds="http://schemas.openxmlformats.org/officeDocument/2006/customXml" ds:itemID="{961A30F4-F1EA-4F98-A164-76D337EE5565}">
-  <ds:schemaRefs>
-    <ds:schemaRef ds:uri="http://schemas.microsoft.com/office/2006/metadata/properties"/>
-    <ds:schemaRef ds:uri="http://schemas.microsoft.com/office/infopath/2007/PartnerControls"/>
-  </ds:schemaRefs>
-</ds:datastoreItem>
 </file>
</xml_diff>